<commit_message>
Explain MCP Atlas task counts and use version terminology
</commit_message>
<xml_diff>
--- a/slides/datasets-in-10-minutes-mcp-atlas.pptx
+++ b/slides/datasets-in-10-minutes-mcp-atlas.pptx
@@ -11880,7 +11880,7 @@
                 <a:ea typeface="Noto Sans CJK JP"/>
                 <a:cs typeface="Noto Sans"/>
               </a:rPr>
-              <a:t>論文の改訂版では、上位モデルは約8割に達する</a:t>
+              <a:t>論文バージョン3では、上位モデルは約8割</a:t>
             </a:r>
           </a:p>
         </p:txBody>
@@ -17772,7 +17772,7 @@
                 <a:ea typeface="Noto Sans CJK JP"/>
                 <a:cs typeface="Noto Sans"/>
               </a:rPr>
-              <a:t>サーバーの実装・依存関係は版を固定し、実行条件を記録する。</a:t>
+              <a:t>サーバーの実装・依存関係はバージョンを固定し、実行条件を記録する。</a:t>
             </a:r>
           </a:p>
         </p:txBody>
@@ -19431,7 +19431,7 @@
                 <a:ea typeface="Noto Sans CJK JP"/>
                 <a:cs typeface="Noto Sans"/>
               </a:rPr>
-              <a:t>版・実装と評価条件</a:t>
+              <a:t>バージョン・実装と評価条件</a:t>
             </a:r>
           </a:p>
           <a:p>
@@ -21021,7 +21021,7 @@
                 <a:ea typeface="Noto Sans CJK JP"/>
                 <a:cs typeface="Noto Sans"/>
               </a:rPr>
-              <a:t>提示する候補から、必要なツールを選ぶ</a:t>
+              <a:t>1課題あたりのツールと正解条件の数</a:t>
             </a:r>
           </a:p>
         </p:txBody>
@@ -21083,19 +21083,19 @@
           <p:nvPr/>
         </p:nvGraphicFramePr>
         <p:xfrm>
-          <a:off x="548640" y="1508760"/>
-          <a:ext cx="8046720" cy="1901952"/>
+          <a:off x="548640" y="1938528"/>
+          <a:ext cx="8046720" cy="1719072"/>
         </p:xfrm>
         <a:graphic>
           <a:graphicData uri="http://schemas.openxmlformats.org/drawingml/2006/table">
             <a:tbl>
               <a:tblPr firstRow="0" bandRow="0"/>
               <a:tblGrid>
-                <a:gridCol w="3931920"/>
-                <a:gridCol w="1828800"/>
+                <a:gridCol w="4023360"/>
+                <a:gridCol w="1737360"/>
                 <a:gridCol w="2286000"/>
               </a:tblGrid>
-              <a:tr h="475488">
+              <a:tr h="429768">
                 <a:tc>
                   <a:txBody>
                     <a:bodyPr wrap="square">
@@ -21105,10 +21105,10 @@
                     <a:p>
                       <a:pPr algn="l">
                         <a:lnSpc>
-                          <a:spcPts val="2300"/>
+                          <a:spcPts val="2200"/>
                         </a:lnSpc>
                         <a:buNone/>
-                        <a:defRPr sz="2000" b="0">
+                        <a:defRPr sz="1850" b="0">
                           <a:solidFill>
                             <a:srgbClr val="303437"/>
                           </a:solidFill>
@@ -21116,7 +21116,7 @@
                         </a:defRPr>
                       </a:pPr>
                       <a:r>
-                        <a:rPr sz="2000" b="0" lang="ja-JP" altLang="en-US">
+                        <a:rPr sz="1850" b="0" lang="ja-JP" altLang="en-US">
                           <a:solidFill>
                             <a:srgbClr val="303437"/>
                           </a:solidFill>
@@ -21124,7 +21124,7 @@
                           <a:ea typeface="Noto Sans CJK JP"/>
                           <a:cs typeface="Noto Sans"/>
                         </a:rPr>
-                        <a:t>構成</a:t>
+                        <a:t>数える対象</a:t>
                       </a:r>
                     </a:p>
                   </a:txBody>
@@ -21161,10 +21161,10 @@
                     <a:p>
                       <a:pPr algn="r">
                         <a:lnSpc>
-                          <a:spcPts val="2300"/>
+                          <a:spcPts val="2200"/>
                         </a:lnSpc>
                         <a:buNone/>
-                        <a:defRPr sz="2000" b="0">
+                        <a:defRPr sz="1850" b="0">
                           <a:solidFill>
                             <a:srgbClr val="303437"/>
                           </a:solidFill>
@@ -21172,7 +21172,7 @@
                         </a:defRPr>
                       </a:pPr>
                       <a:r>
-                        <a:rPr sz="2000" b="0" lang="ja-JP" altLang="en-US">
+                        <a:rPr sz="1850" b="0" lang="ja-JP" altLang="en-US">
                           <a:solidFill>
                             <a:srgbClr val="303437"/>
                           </a:solidFill>
@@ -21180,7 +21180,7 @@
                           <a:ea typeface="Noto Sans CJK JP"/>
                           <a:cs typeface="Noto Sans"/>
                         </a:rPr>
-                        <a:t>平均</a:t>
+                        <a:t>1課題の平均</a:t>
                       </a:r>
                     </a:p>
                   </a:txBody>
@@ -21217,10 +21217,10 @@
                     <a:p>
                       <a:pPr algn="r">
                         <a:lnSpc>
-                          <a:spcPts val="2300"/>
+                          <a:spcPts val="2200"/>
                         </a:lnSpc>
                         <a:buNone/>
-                        <a:defRPr sz="2000" b="0">
+                        <a:defRPr sz="1850" b="0">
                           <a:solidFill>
                             <a:srgbClr val="303437"/>
                           </a:solidFill>
@@ -21228,7 +21228,7 @@
                         </a:defRPr>
                       </a:pPr>
                       <a:r>
-                        <a:rPr sz="2000" b="0" lang="ja-JP" altLang="en-US">
+                        <a:rPr sz="1850" b="0" lang="ja-JP" altLang="en-US">
                           <a:solidFill>
                             <a:srgbClr val="303437"/>
                           </a:solidFill>
@@ -21236,7 +21236,7 @@
                           <a:ea typeface="Noto Sans CJK JP"/>
                           <a:cs typeface="Noto Sans"/>
                         </a:rPr>
-                        <a:t>範囲</a:t>
+                        <a:t>最小〜最大</a:t>
                       </a:r>
                     </a:p>
                   </a:txBody>
@@ -21265,7 +21265,7 @@
                   </a:tcPr>
                 </a:tc>
               </a:tr>
-              <a:tr h="475488">
+              <a:tr h="429768">
                 <a:tc>
                   <a:txBody>
                     <a:bodyPr wrap="square">
@@ -21275,10 +21275,10 @@
                     <a:p>
                       <a:pPr algn="l">
                         <a:lnSpc>
-                          <a:spcPts val="2300"/>
+                          <a:spcPts val="2200"/>
                         </a:lnSpc>
                         <a:buNone/>
-                        <a:defRPr sz="2000" b="0">
+                        <a:defRPr sz="1850" b="0">
                           <a:solidFill>
                             <a:srgbClr val="303437"/>
                           </a:solidFill>
@@ -21286,7 +21286,7 @@
                         </a:defRPr>
                       </a:pPr>
                       <a:r>
-                        <a:rPr sz="2000" b="0" lang="ja-JP" altLang="en-US">
+                        <a:rPr sz="1850" b="0" lang="ja-JP" altLang="en-US">
                           <a:solidFill>
                             <a:srgbClr val="303437"/>
                           </a:solidFill>
@@ -21294,7 +21294,7 @@
                           <a:ea typeface="Noto Sans CJK JP"/>
                           <a:cs typeface="Noto Sans"/>
                         </a:rPr>
-                        <a:t>提示ツール</a:t>
+                        <a:t>提示するツールの種類数</a:t>
                       </a:r>
                     </a:p>
                   </a:txBody>
@@ -21328,10 +21328,10 @@
                     <a:p>
                       <a:pPr algn="r">
                         <a:lnSpc>
-                          <a:spcPts val="2300"/>
+                          <a:spcPts val="2200"/>
                         </a:lnSpc>
                         <a:buNone/>
-                        <a:defRPr sz="2000" b="0">
+                        <a:defRPr sz="1850" b="0">
                           <a:solidFill>
                             <a:srgbClr val="303437"/>
                           </a:solidFill>
@@ -21339,7 +21339,7 @@
                         </a:defRPr>
                       </a:pPr>
                       <a:r>
-                        <a:rPr sz="2000" b="0" lang="ja-JP" altLang="en-US">
+                        <a:rPr sz="1850" b="0" lang="ja-JP" altLang="en-US">
                           <a:solidFill>
                             <a:srgbClr val="303437"/>
                           </a:solidFill>
@@ -21347,7 +21347,7 @@
                           <a:ea typeface="Noto Sans CJK JP"/>
                           <a:cs typeface="Noto Sans"/>
                         </a:rPr>
-                        <a:t>15.2</a:t>
+                        <a:t>15.2種類</a:t>
                       </a:r>
                     </a:p>
                   </a:txBody>
@@ -21381,10 +21381,10 @@
                     <a:p>
                       <a:pPr algn="r">
                         <a:lnSpc>
-                          <a:spcPts val="2300"/>
+                          <a:spcPts val="2200"/>
                         </a:lnSpc>
                         <a:buNone/>
-                        <a:defRPr sz="2000" b="0">
+                        <a:defRPr sz="1850" b="0">
                           <a:solidFill>
                             <a:srgbClr val="303437"/>
                           </a:solidFill>
@@ -21392,7 +21392,7 @@
                         </a:defRPr>
                       </a:pPr>
                       <a:r>
-                        <a:rPr sz="2000" b="0" lang="ja-JP" altLang="en-US">
+                        <a:rPr sz="1850" b="0" lang="ja-JP" altLang="en-US">
                           <a:solidFill>
                             <a:srgbClr val="303437"/>
                           </a:solidFill>
@@ -21400,7 +21400,7 @@
                           <a:ea typeface="Noto Sans CJK JP"/>
                           <a:cs typeface="Noto Sans"/>
                         </a:rPr>
-                        <a:t>6〜37</a:t>
+                        <a:t>6〜37種類</a:t>
                       </a:r>
                     </a:p>
                   </a:txBody>
@@ -21426,7 +21426,7 @@
                   </a:tcPr>
                 </a:tc>
               </a:tr>
-              <a:tr h="475488">
+              <a:tr h="429768">
                 <a:tc>
                   <a:txBody>
                     <a:bodyPr wrap="square">
@@ -21436,10 +21436,10 @@
                     <a:p>
                       <a:pPr algn="l">
                         <a:lnSpc>
-                          <a:spcPts val="2300"/>
+                          <a:spcPts val="2200"/>
                         </a:lnSpc>
                         <a:buNone/>
-                        <a:defRPr sz="2000" b="0">
+                        <a:defRPr sz="1850" b="0">
                           <a:solidFill>
                             <a:srgbClr val="303437"/>
                           </a:solidFill>
@@ -21447,7 +21447,7 @@
                         </a:defRPr>
                       </a:pPr>
                       <a:r>
-                        <a:rPr sz="2000" b="0" lang="ja-JP" altLang="en-US">
+                        <a:rPr sz="1850" b="0" lang="ja-JP" altLang="en-US">
                           <a:solidFill>
                             <a:srgbClr val="303437"/>
                           </a:solidFill>
@@ -21455,7 +21455,7 @@
                           <a:ea typeface="Noto Sans CJK JP"/>
                           <a:cs typeface="Noto Sans"/>
                         </a:rPr>
-                        <a:t>必要ツール</a:t>
+                        <a:t>解答に必要なツールの種類数</a:t>
                       </a:r>
                     </a:p>
                   </a:txBody>
@@ -21486,10 +21486,10 @@
                     <a:p>
                       <a:pPr algn="r">
                         <a:lnSpc>
-                          <a:spcPts val="2300"/>
+                          <a:spcPts val="2200"/>
                         </a:lnSpc>
                         <a:buNone/>
-                        <a:defRPr sz="2000" b="0">
+                        <a:defRPr sz="1850" b="0">
                           <a:solidFill>
                             <a:srgbClr val="303437"/>
                           </a:solidFill>
@@ -21497,7 +21497,7 @@
                         </a:defRPr>
                       </a:pPr>
                       <a:r>
-                        <a:rPr sz="2000" b="0" lang="ja-JP" altLang="en-US">
+                        <a:rPr sz="1850" b="0" lang="ja-JP" altLang="en-US">
                           <a:solidFill>
                             <a:srgbClr val="303437"/>
                           </a:solidFill>
@@ -21505,7 +21505,7 @@
                           <a:ea typeface="Noto Sans CJK JP"/>
                           <a:cs typeface="Noto Sans"/>
                         </a:rPr>
-                        <a:t>4.1</a:t>
+                        <a:t>4.1種類</a:t>
                       </a:r>
                     </a:p>
                   </a:txBody>
@@ -21536,10 +21536,10 @@
                     <a:p>
                       <a:pPr algn="r">
                         <a:lnSpc>
-                          <a:spcPts val="2300"/>
+                          <a:spcPts val="2200"/>
                         </a:lnSpc>
                         <a:buNone/>
-                        <a:defRPr sz="2000" b="0">
+                        <a:defRPr sz="1850" b="0">
                           <a:solidFill>
                             <a:srgbClr val="303437"/>
                           </a:solidFill>
@@ -21547,7 +21547,7 @@
                         </a:defRPr>
                       </a:pPr>
                       <a:r>
-                        <a:rPr sz="2000" b="0" lang="ja-JP" altLang="en-US">
+                        <a:rPr sz="1850" b="0" lang="ja-JP" altLang="en-US">
                           <a:solidFill>
                             <a:srgbClr val="303437"/>
                           </a:solidFill>
@@ -21555,7 +21555,7 @@
                           <a:ea typeface="Noto Sans CJK JP"/>
                           <a:cs typeface="Noto Sans"/>
                         </a:rPr>
-                        <a:t>2〜8</a:t>
+                        <a:t>2〜8種類</a:t>
                       </a:r>
                     </a:p>
                   </a:txBody>
@@ -21578,7 +21578,7 @@
                   </a:tcPr>
                 </a:tc>
               </a:tr>
-              <a:tr h="475488">
+              <a:tr h="429768">
                 <a:tc>
                   <a:txBody>
                     <a:bodyPr wrap="square">
@@ -21588,10 +21588,10 @@
                     <a:p>
                       <a:pPr algn="l">
                         <a:lnSpc>
-                          <a:spcPts val="2300"/>
+                          <a:spcPts val="2200"/>
                         </a:lnSpc>
                         <a:buNone/>
-                        <a:defRPr sz="2000" b="0">
+                        <a:defRPr sz="1850" b="0">
                           <a:solidFill>
                             <a:srgbClr val="303437"/>
                           </a:solidFill>
@@ -21599,7 +21599,7 @@
                         </a:defRPr>
                       </a:pPr>
                       <a:r>
-                        <a:rPr sz="2000" b="0" lang="ja-JP" altLang="en-US">
+                        <a:rPr sz="1850" b="0" lang="ja-JP" altLang="en-US">
                           <a:solidFill>
                             <a:srgbClr val="303437"/>
                           </a:solidFill>
@@ -21607,7 +21607,7 @@
                           <a:ea typeface="Noto Sans CJK JP"/>
                           <a:cs typeface="Noto Sans"/>
                         </a:rPr>
-                        <a:t>正解条件</a:t>
+                        <a:t>回答の正解条件の数</a:t>
                       </a:r>
                     </a:p>
                   </a:txBody>
@@ -21641,10 +21641,10 @@
                     <a:p>
                       <a:pPr algn="r">
                         <a:lnSpc>
-                          <a:spcPts val="2300"/>
+                          <a:spcPts val="2200"/>
                         </a:lnSpc>
                         <a:buNone/>
-                        <a:defRPr sz="2000" b="0">
+                        <a:defRPr sz="1850" b="0">
                           <a:solidFill>
                             <a:srgbClr val="303437"/>
                           </a:solidFill>
@@ -21652,7 +21652,7 @@
                         </a:defRPr>
                       </a:pPr>
                       <a:r>
-                        <a:rPr sz="2000" b="0" lang="ja-JP" altLang="en-US">
+                        <a:rPr sz="1850" b="0" lang="ja-JP" altLang="en-US">
                           <a:solidFill>
                             <a:srgbClr val="303437"/>
                           </a:solidFill>
@@ -21660,7 +21660,7 @@
                           <a:ea typeface="Noto Sans CJK JP"/>
                           <a:cs typeface="Noto Sans"/>
                         </a:rPr>
-                        <a:t>4.7</a:t>
+                        <a:t>4.7項目</a:t>
                       </a:r>
                     </a:p>
                   </a:txBody>
@@ -21694,10 +21694,10 @@
                     <a:p>
                       <a:pPr algn="r">
                         <a:lnSpc>
-                          <a:spcPts val="2300"/>
+                          <a:spcPts val="2200"/>
                         </a:lnSpc>
                         <a:buNone/>
-                        <a:defRPr sz="2000" b="0">
+                        <a:defRPr sz="1850" b="0">
                           <a:solidFill>
                             <a:srgbClr val="303437"/>
                           </a:solidFill>
@@ -21705,7 +21705,7 @@
                         </a:defRPr>
                       </a:pPr>
                       <a:r>
-                        <a:rPr sz="2000" b="0" lang="ja-JP" altLang="en-US">
+                        <a:rPr sz="1850" b="0" lang="ja-JP" altLang="en-US">
                           <a:solidFill>
                             <a:srgbClr val="303437"/>
                           </a:solidFill>
@@ -21713,7 +21713,7 @@
                           <a:ea typeface="Noto Sans CJK JP"/>
                           <a:cs typeface="Noto Sans"/>
                         </a:rPr>
-                        <a:t>1〜23</a:t>
+                        <a:t>1〜23項目</a:t>
                       </a:r>
                     </a:p>
                   </a:txBody>
@@ -21751,8 +21751,8 @@
         </p:nvSpPr>
         <p:spPr>
           <a:xfrm>
-            <a:off x="594360" y="3602736"/>
-            <a:ext cx="7955279" cy="685800"/>
+            <a:off x="594360" y="3858768"/>
+            <a:ext cx="7955279" cy="667512"/>
           </a:xfrm>
           <a:prstGeom prst="rect">
             <a:avLst/>
@@ -21767,7 +21767,7 @@
           <a:p>
             <a:pPr algn="l">
               <a:lnSpc>
-                <a:spcPts val="2160"/>
+                <a:spcPts val="2300"/>
               </a:lnSpc>
               <a:spcBef>
                 <a:spcPts val="0"/>
@@ -21792,13 +21792,13 @@
                 <a:ea typeface="Noto Sans CJK JP"/>
                 <a:cs typeface="Noto Sans"/>
               </a:rPr>
-              <a:t>全1,000課題の論文集計。</a:t>
+              <a:t>種類数はツールの機能の数。同じ機能を繰り返し呼ぶこともある。</a:t>
             </a:r>
           </a:p>
           <a:p>
             <a:pPr algn="l">
               <a:lnSpc>
-                <a:spcPts val="2160"/>
+                <a:spcPts val="2300"/>
               </a:lnSpc>
               <a:spcBef>
                 <a:spcPts val="0"/>
@@ -21823,7 +21823,7 @@
                 <a:ea typeface="Noto Sans CJK JP"/>
                 <a:cs typeface="Noto Sans"/>
               </a:rPr>
-              <a:t>参照の操作履歴は、1課題平均9.8ツール呼び出し。</a:t>
+              <a:t>参照の操作履歴は、1課題あたり平均9.8回のツール呼び出し。</a:t>
             </a:r>
           </a:p>
         </p:txBody>
@@ -21912,6 +21912,47 @@
                 <a:hlinkClick r:id="rId2"/>
               </a:rPr>
               <a:t>https://arxiv.org/abs/2602.00933v3</a:t>
+            </a:r>
+          </a:p>
+        </p:txBody>
+      </p:sp>
+      <p:sp>
+        <p:nvSpPr>
+          <p:cNvPr id="7" name="TextBox 6"/>
+          <p:cNvSpPr txBox="1"/>
+          <p:nvPr/>
+        </p:nvSpPr>
+        <p:spPr>
+          <a:xfrm>
+            <a:off x="594360" y="1417320"/>
+            <a:ext cx="7955279" cy="320040"/>
+          </a:xfrm>
+          <a:prstGeom prst="rect">
+            <a:avLst/>
+          </a:prstGeom>
+          <a:noFill/>
+        </p:spPr>
+        <p:txBody>
+          <a:bodyPr wrap="none" lIns="0" rIns="0" tIns="0" bIns="0">
+            <a:spAutoFit/>
+          </a:bodyPr>
+          <a:lstStyle/>
+          <a:p>
+            <a:pPr>
+              <a:lnSpc>
+                <a:spcPts val="2300"/>
+              </a:lnSpc>
+            </a:pPr>
+            <a:r>
+              <a:rPr sz="1800" b="0" lang="ja-JP" altLang="en-US">
+                <a:solidFill>
+                  <a:srgbClr val="303437"/>
+                </a:solidFill>
+                <a:latin typeface="Noto Sans"/>
+                <a:ea typeface="Noto Sans CJK JP"/>
+                <a:cs typeface="Noto Sans"/>
+              </a:rPr>
+              <a:t>全1,000課題を集計。平均は1課題あたり、範囲は最小〜最大。</a:t>
             </a:r>
           </a:p>
         </p:txBody>
@@ -23917,7 +23958,7 @@
                 <a:ea typeface="Noto Sans CJK JP"/>
                 <a:cs typeface="Noto Sans"/>
               </a:rPr>
-              <a:t>2. 版・実装と評価条件</a:t>
+              <a:t>2. バージョン・実装と評価条件</a:t>
             </a:r>
           </a:p>
         </p:txBody>
@@ -23965,7 +24006,7 @@
                 <a:ea typeface="Noto Sans CJK JP"/>
                 <a:cs typeface="Noto Sans"/>
               </a:rPr>
-              <a:t>Appendix: 2. 版・実装と評価条件</a:t>
+              <a:t>Appendix: 2. バージョン・実装と評価条件</a:t>
             </a:r>
           </a:p>
         </p:txBody>
@@ -24031,7 +24072,7 @@
                 <a:ea typeface="Noto Sans CJK JP"/>
                 <a:cs typeface="Noto Sans"/>
               </a:rPr>
-              <a:t>論文の改訂版は、判定器を変えた結果も示す</a:t>
+              <a:t>論文バージョン3は、判定器も比較する</a:t>
             </a:r>
           </a:p>
         </p:txBody>
@@ -24079,7 +24120,7 @@
                 <a:ea typeface="Noto Sans CJK JP"/>
                 <a:cs typeface="Noto Sans"/>
               </a:rPr>
-              <a:t>Appendix: 2. 版・実装と評価条件</a:t>
+              <a:t>Appendix: 2. バージョン・実装と評価条件</a:t>
             </a:r>
           </a:p>
         </p:txBody>
@@ -25248,7 +25289,7 @@
                 <a:ea typeface="Noto Sans CJK JP"/>
                 <a:cs typeface="Noto Sans"/>
               </a:rPr>
-              <a:t>Appendix: 2. 版・実装と評価条件</a:t>
+              <a:t>Appendix: 2. バージョン・実装と評価条件</a:t>
             </a:r>
           </a:p>
         </p:txBody>
@@ -26530,7 +26571,7 @@
                 <a:ea typeface="Noto Sans CJK JP"/>
                 <a:cs typeface="Noto Sans"/>
               </a:rPr>
-              <a:t>Appendix: 2. 版・実装と評価条件</a:t>
+              <a:t>Appendix: 2. バージョン・実装と評価条件</a:t>
             </a:r>
           </a:p>
         </p:txBody>

</xml_diff>

<commit_message>
Show official name expansions on covers and require thorough example research
</commit_message>
<xml_diff>
--- a/slides/datasets-in-10-minutes-mcp-atlas.pptx
+++ b/slides/datasets-in-10-minutes-mcp-atlas.pptx
@@ -7796,8 +7796,8 @@
         </p:nvSpPr>
         <p:spPr>
           <a:xfrm>
-            <a:off x="548640" y="2066543"/>
-            <a:ext cx="8046720" cy="685800"/>
+            <a:off x="457200" y="1649730"/>
+            <a:ext cx="8229600" cy="863600"/>
           </a:xfrm>
         </p:spPr>
         <p:txBody>
@@ -7844,8 +7844,8 @@
         </p:nvSpPr>
         <p:spPr>
           <a:xfrm>
-            <a:off x="640080" y="2944368"/>
-            <a:ext cx="7863840" cy="822960"/>
+            <a:off x="457200" y="3186430"/>
+            <a:ext cx="8229600" cy="812800"/>
           </a:xfrm>
         </p:spPr>
         <p:txBody>
@@ -7973,6 +7973,53 @@
                 <a:cs typeface="Noto Sans"/>
               </a:rPr>
               <a:t>datasets in 10 minutes (2026-10-16)</a:t>
+            </a:r>
+          </a:p>
+        </p:txBody>
+      </p:sp>
+      <p:sp>
+        <p:nvSpPr>
+          <p:cNvPr id="7" name="正式名称・略語の展開"/>
+          <p:cNvSpPr txBox="1"/>
+          <p:nvPr/>
+        </p:nvSpPr>
+        <p:spPr>
+          <a:xfrm>
+            <a:off x="457200" y="2678430"/>
+            <a:ext cx="8229600" cy="406400"/>
+          </a:xfrm>
+          <a:prstGeom prst="rect">
+            <a:avLst/>
+          </a:prstGeom>
+          <a:noFill/>
+        </p:spPr>
+        <p:txBody>
+          <a:bodyPr wrap="square" lIns="0" rIns="0" tIns="0" bIns="0">
+            <a:noAutofit/>
+          </a:bodyPr>
+          <a:lstStyle/>
+          <a:p>
+            <a:pPr algn="ctr">
+              <a:lnSpc>
+                <a:spcPct val="115000"/>
+              </a:lnSpc>
+              <a:spcBef>
+                <a:spcPts val="0"/>
+              </a:spcBef>
+              <a:spcAft>
+                <a:spcPts val="0"/>
+              </a:spcAft>
+            </a:pPr>
+            <a:r>
+              <a:rPr sz="2100" b="0">
+                <a:solidFill>
+                  <a:srgbClr val="626669"/>
+                </a:solidFill>
+                <a:latin typeface="Noto Sans"/>
+                <a:ea typeface="Noto Sans CJK JP"/>
+                <a:cs typeface="Noto Sans"/>
+              </a:rPr>
+              <a:t>MCP = Model Context Protocol</a:t>
             </a:r>
           </a:p>
         </p:txBody>

</xml_diff>

<commit_message>
Remove redundant MMMU and MCP expansions from slides
</commit_message>
<xml_diff>
--- a/slides/datasets-in-10-minutes-mcp-atlas.pptx
+++ b/slides/datasets-in-10-minutes-mcp-atlas.pptx
@@ -7796,7 +7796,7 @@
         </p:nvSpPr>
         <p:spPr>
           <a:xfrm>
-            <a:off x="457200" y="1649730"/>
+            <a:off x="457200" y="1836991"/>
             <a:ext cx="8229600" cy="863600"/>
           </a:xfrm>
         </p:spPr>
@@ -7844,7 +7844,7 @@
         </p:nvSpPr>
         <p:spPr>
           <a:xfrm>
-            <a:off x="457200" y="3186430"/>
+            <a:off x="457200" y="2998279"/>
             <a:ext cx="8229600" cy="812800"/>
           </a:xfrm>
         </p:spPr>
@@ -7973,53 +7973,6 @@
                 <a:cs typeface="Noto Sans"/>
               </a:rPr>
               <a:t>datasets in 10 minutes (2026-10-16)</a:t>
-            </a:r>
-          </a:p>
-        </p:txBody>
-      </p:sp>
-      <p:sp>
-        <p:nvSpPr>
-          <p:cNvPr id="7" name="正式名称・略語の展開"/>
-          <p:cNvSpPr txBox="1"/>
-          <p:nvPr/>
-        </p:nvSpPr>
-        <p:spPr>
-          <a:xfrm>
-            <a:off x="457200" y="2678430"/>
-            <a:ext cx="8229600" cy="406400"/>
-          </a:xfrm>
-          <a:prstGeom prst="rect">
-            <a:avLst/>
-          </a:prstGeom>
-          <a:noFill/>
-        </p:spPr>
-        <p:txBody>
-          <a:bodyPr wrap="square" lIns="0" rIns="0" tIns="0" bIns="0">
-            <a:noAutofit/>
-          </a:bodyPr>
-          <a:lstStyle/>
-          <a:p>
-            <a:pPr algn="ctr">
-              <a:lnSpc>
-                <a:spcPct val="115000"/>
-              </a:lnSpc>
-              <a:spcBef>
-                <a:spcPts val="0"/>
-              </a:spcBef>
-              <a:spcAft>
-                <a:spcPts val="0"/>
-              </a:spcAft>
-            </a:pPr>
-            <a:r>
-              <a:rPr sz="2100" b="0">
-                <a:solidFill>
-                  <a:srgbClr val="626669"/>
-                </a:solidFill>
-                <a:latin typeface="Noto Sans"/>
-                <a:ea typeface="Noto Sans CJK JP"/>
-                <a:cs typeface="Noto Sans"/>
-              </a:rPr>
-              <a:t>MCP = Model Context Protocol</a:t>
             </a:r>
           </a:p>
         </p:txBody>
@@ -24903,7 +24856,7 @@
                 <a:ea typeface="Noto Sans CJK JP"/>
                 <a:cs typeface="Noto Sans"/>
               </a:rPr>
-              <a:t>MCP（Model Context Protocol）は、モデルが外部のデータや機能へアクセスするための共通の接続方式。サーバーは検索・ファイル・データベースなどのツールを提供する。</a:t>
+              <a:t>MCPは、モデルが外部のデータや機能へアクセスするための共通の接続方式。サーバーは検索・ファイル・データベースなどのツールを提供する。</a:t>
             </a:r>
           </a:p>
           <a:p>

</xml_diff>

<commit_message>
Proofread mcp-atlas with Japanese proofreading skill
</commit_message>
<xml_diff>
--- a/slides/datasets-in-10-minutes-mcp-atlas.pptx
+++ b/slides/datasets-in-10-minutes-mcp-atlas.pptx
@@ -8402,7 +8402,7 @@
                 <a:ea typeface="Noto Sans CJK JP"/>
                 <a:cs typeface="Noto Sans"/>
               </a:rPr>
-              <a:t>外部の出来事を、社内データの期間指定へ使う</a:t>
+              <a:t>外部の出来事を、社内データの期間指定に使う</a:t>
             </a:r>
           </a:p>
         </p:txBody>
@@ -11882,23 +11882,23 @@
                 <a:spcPct val="110000"/>
               </a:lnSpc>
               <a:buNone/>
-              <a:defRPr sz="2800" b="0">
-                <a:solidFill>
-                  <a:srgbClr val="303437"/>
-                </a:solidFill>
-                <a:latin typeface="Noto Sans"/>
-              </a:defRPr>
-            </a:pPr>
-            <a:r>
-              <a:rPr sz="2800" b="1" lang="ja-JP" altLang="en-US">
-                <a:solidFill>
-                  <a:srgbClr val="303437"/>
-                </a:solidFill>
-                <a:latin typeface="Noto Sans"/>
-                <a:ea typeface="Noto Sans CJK JP"/>
-                <a:cs typeface="Noto Sans"/>
-              </a:rPr>
-              <a:t>論文バージョン3では、上位モデルは約8割</a:t>
+              <a:defRPr sz="2500" b="0">
+                <a:solidFill>
+                  <a:srgbClr val="303437"/>
+                </a:solidFill>
+                <a:latin typeface="Noto Sans"/>
+              </a:defRPr>
+            </a:pPr>
+            <a:r>
+              <a:rPr sz="2500" b="1" lang="ja-JP" altLang="en-US">
+                <a:solidFill>
+                  <a:srgbClr val="303437"/>
+                </a:solidFill>
+                <a:latin typeface="Noto Sans"/>
+                <a:ea typeface="Noto Sans CJK JP"/>
+                <a:cs typeface="Noto Sans"/>
+              </a:rPr>
+              <a:t>論文バージョン3では、上位モデルの合格率は約8割</a:t>
             </a:r>
           </a:p>
         </p:txBody>
@@ -13403,7 +13403,7 @@
                 <a:ea typeface="Noto Sans CJK JP"/>
                 <a:cs typeface="Noto Sans"/>
               </a:rPr>
-              <a:t>Gemini 3.1 Proの公式Performance表で採用。</a:t>
+              <a:t>表の評価データはGemini 3.1 Proの公式比較に掲載。</a:t>
             </a:r>
           </a:p>
           <a:p>
@@ -14243,7 +14243,7 @@
                 <a:ea typeface="Noto Sans CJK JP"/>
                 <a:cs typeface="Noto Sans"/>
               </a:rPr>
-              <a:t>専門家が、外部データの必要な仕事を作る</a:t>
+              <a:t>専門家が、外部データが必要な課題を作る</a:t>
             </a:r>
           </a:p>
         </p:txBody>
@@ -14356,7 +14356,7 @@
                 <a:ea typeface="Noto Sans CJK JP"/>
                 <a:cs typeface="Noto Sans"/>
               </a:rPr>
-              <a:t>参照の操作履歴と、ツールの返した情報に基づく最終回答を用意する。1課題の作成・検証・文書化は平均4.6時間。</a:t>
+              <a:t>参照用の操作履歴と、ツールの返した情報に基づく最終回答を用意する。1課題の作成・検証・文書化は平均4.6時間。</a:t>
             </a:r>
           </a:p>
         </p:txBody>
@@ -15031,7 +15031,7 @@
                           <a:ea typeface="Noto Sans CJK JP"/>
                           <a:cs typeface="Noto Sans"/>
                         </a:rPr>
-                        <a:t>確かめる内容</a:t>
+                        <a:t>検証内容</a:t>
                       </a:r>
                     </a:p>
                   </a:txBody>
@@ -15299,7 +15299,7 @@
                           <a:ea typeface="Noto Sans CJK JP"/>
                           <a:cs typeface="Noto Sans"/>
                         </a:rPr>
-                        <a:t>別のレビュー</a:t>
+                        <a:t>別担当者によるレビュー</a:t>
                       </a:r>
                     </a:p>
                   </a:txBody>
@@ -16129,7 +16129,7 @@
                 <a:ea typeface="Noto Sans CJK JP"/>
                 <a:cs typeface="Noto Sans"/>
               </a:rPr>
-              <a:t>全1,000課題の必要サーバー数の割合（%）。平均2.55。</a:t>
+              <a:t>全1,000課題の必要サーバー数の割合（%）。平均2.55サーバー。</a:t>
             </a:r>
           </a:p>
         </p:txBody>
@@ -16283,7 +16283,7 @@
                 <a:ea typeface="Noto Sans CJK JP"/>
                 <a:cs typeface="Noto Sans"/>
               </a:rPr>
-              <a:t>公開500課題には、依頼と正解条件を配布する</a:t>
+              <a:t>公開500課題では、依頼と正解条件を配布する</a:t>
             </a:r>
           </a:p>
         </p:txBody>
@@ -16823,7 +16823,7 @@
                           <a:ea typeface="Noto Sans CJK JP"/>
                           <a:cs typeface="Noto Sans"/>
                         </a:rPr>
-                        <a:t>運営側で保持する評価用の課題</a:t>
+                        <a:t>入手不可（運営側で保持する評価用課題）</a:t>
                       </a:r>
                     </a:p>
                   </a:txBody>
@@ -17201,7 +17201,7 @@
                 <a:ea typeface="Noto Sans CJK JP"/>
                 <a:cs typeface="Noto Sans"/>
               </a:rPr>
-              <a:t>MCPサーバーを固定したコンテナーで動かす</a:t>
+              <a:t>バージョンを固定したMCPサーバーを動かす</a:t>
             </a:r>
           </a:p>
         </p:txBody>
@@ -17359,7 +17359,7 @@
                           <a:ea typeface="Noto Sans CJK JP"/>
                           <a:cs typeface="Noto Sans"/>
                         </a:rPr>
-                        <a:t>使うもの</a:t>
+                        <a:t>実装・動作内容</a:t>
                       </a:r>
                     </a:p>
                   </a:txBody>
@@ -18990,7 +18990,7 @@
                 <a:ea typeface="Noto Sans CJK JP"/>
                 <a:cs typeface="Noto Sans"/>
               </a:rPr>
-              <a:t>MCP Atlasは、自然な依頼に対して、必要なツールを探し、複数サーバーの結果をつないで回答を作る評価。</a:t>
+              <a:t>MCP Atlasは、自然な依頼に対して、必要なツールを探し、複数サーバーの結果をつないで回答を作る能力を評価する。</a:t>
             </a:r>
           </a:p>
           <a:p>
@@ -21212,7 +21212,7 @@
                 <a:ea typeface="Noto Sans CJK JP"/>
                 <a:cs typeface="Noto Sans"/>
               </a:rPr>
-              <a:t>参照履歴は、ローカルのディレクトリや複数ファイルを読み、端末コマンドでコード量と依存情報を確認する。</a:t>
+              <a:t>参照履歴では、ローカルのディレクトリや複数ファイルを読み、端末コマンドでコード量と依存情報を確認している。</a:t>
             </a:r>
           </a:p>
         </p:txBody>
@@ -21975,7 +21975,7 @@
                 <a:ea typeface="Noto Sans CJK JP"/>
                 <a:cs typeface="Noto Sans"/>
               </a:rPr>
-              <a:t>参照履歴は、端末でリポジトリを調べ、Gitの履歴を取得する。コードで対象コミットを絞り、Gitで変更内容を読む。</a:t>
+              <a:t>参照履歴では、端末でリポジトリを調べ、Gitの履歴を取得する。コードで対象コミットを絞り、Gitで変更内容を読む。</a:t>
             </a:r>
           </a:p>
         </p:txBody>
@@ -22624,7 +22624,7 @@
                 <a:ea typeface="Noto Sans CJK JP"/>
                 <a:cs typeface="Noto Sans"/>
               </a:rPr>
-              <a:t>参照履歴は、Slackのチャンネルとメッセージを検索した後、ローカルのディレクトリを探して該当ファイルを読む。</a:t>
+              <a:t>参照履歴では、Slackのチャンネルとメッセージを検索した後、ローカルのディレクトリを探して該当ファイルを読んでいる。</a:t>
             </a:r>
           </a:p>
         </p:txBody>
@@ -23273,7 +23273,7 @@
                 <a:ea typeface="Noto Sans CJK JP"/>
                 <a:cs typeface="Noto Sans"/>
               </a:rPr>
-              <a:t>参照履歴は、メモリーサーバーの組織グラフを読み、Notionで満足度調査のデータベースを検索・照会する。</a:t>
+              <a:t>参照履歴では、メモリーサーバーの組織グラフを読み、Notionで満足度調査のデータベースを検索・照会している。</a:t>
             </a:r>
           </a:p>
         </p:txBody>
@@ -23839,7 +23839,7 @@
                 <a:ea typeface="Noto Sans CJK JP"/>
                 <a:cs typeface="Noto Sans"/>
               </a:rPr>
-              <a:t>二つの日付を特定し、同じ期間の価格を比べる</a:t>
+              <a:t>二つの日付を特定し、その期間の価格を比べる</a:t>
             </a:r>
           </a:p>
         </p:txBody>
@@ -23922,7 +23922,7 @@
                 <a:ea typeface="Noto Sans CJK JP"/>
                 <a:cs typeface="Noto Sans"/>
               </a:rPr>
-              <a:t>配布正解の価格変化率は約47.03%の上昇。参照履歴はWeb検索で日付を確認し、AlchemyでEthereumの価格履歴を取得してコードで計算する。</a:t>
+              <a:t>配布正解の価格変化率は約47.03%の上昇。参照履歴ではWeb検索で日付を確認し、AlchemyでEthereumの価格履歴を取得してコードで計算している。</a:t>
             </a:r>
           </a:p>
         </p:txBody>
@@ -24571,7 +24571,7 @@
                 <a:ea typeface="Noto Sans CJK JP"/>
                 <a:cs typeface="Noto Sans"/>
               </a:rPr>
-              <a:t>2025年8月11日の日最高気温は30.6℃。参照履歴は、公園情報と案内所を検索してから、その地点の気象履歴を取得する。</a:t>
+              <a:t>2025年8月11日の日最高気温は30.6℃。参照履歴では、公園情報と案内所を検索してから、その地点の気象履歴を取得している。</a:t>
             </a:r>
           </a:p>
         </p:txBody>
@@ -24826,7 +24826,7 @@
                 <a:ea typeface="Noto Sans CJK JP"/>
                 <a:cs typeface="Noto Sans"/>
               </a:rPr>
-              <a:t>MCP Atlasは、自然言語で頼まれた仕事を、外部ツールを使って完了できるかを評価する。</a:t>
+              <a:t>MCPは、モデルが外部のデータや機能へアクセスするための共通の接続方式。サーバーは検索・ファイル・データベースなどのツールを提供する。</a:t>
             </a:r>
           </a:p>
           <a:p>
@@ -24856,7 +24856,7 @@
                 <a:ea typeface="Noto Sans CJK JP"/>
                 <a:cs typeface="Noto Sans"/>
               </a:rPr>
-              <a:t>MCPは、モデルが外部のデータや機能へアクセスするための共通の接続方式。サーバーは検索・ファイル・データベースなどのツールを提供する。</a:t>
+              <a:t>MCP Atlasは、自然言語で頼まれた仕事を、外部ツールを使って完了できるかを評価する。</a:t>
             </a:r>
           </a:p>
           <a:p>
@@ -25535,7 +25535,7 @@
                 <a:ea typeface="Noto Sans CJK JP"/>
                 <a:cs typeface="Noto Sans"/>
               </a:rPr>
-              <a:t>参照履歴は、Metの所蔵品検索で作品を見つけて詳細を読み、DuckDuckGoで工房の歴史を検索する。</a:t>
+              <a:t>参照履歴では、Metの所蔵品検索で作品を見つけて詳細を読み、DuckDuckGoで工房の歴史を検索している。</a:t>
             </a:r>
           </a:p>
         </p:txBody>
@@ -26184,7 +26184,7 @@
                 <a:ea typeface="Noto Sans CJK JP"/>
                 <a:cs typeface="Noto Sans"/>
               </a:rPr>
-              <a:t>家族の映画鑑賞会は2025年7月29日、20:00〜22:00（ET）。参照履歴は、ローカルの映画ファイルを読み、Google Workspaceの予定を取得する。</a:t>
+              <a:t>家族の映画鑑賞会は2025年7月29日、20:00〜22:00（ET）。参照履歴では、ローカルの映画ファイルを読み、Google Workspaceの予定を取得する。</a:t>
             </a:r>
           </a:p>
         </p:txBody>
@@ -26833,7 +26833,7 @@
                 <a:ea typeface="Noto Sans CJK JP"/>
                 <a:cs typeface="Noto Sans"/>
               </a:rPr>
-              <a:t>参照履歴は、端末でローカルファイルを探し、コード実行サーバーでCSVを集計する。依頼の対象でないBarber 3は比較に含めない。</a:t>
+              <a:t>参照履歴では、端末でローカルファイルを探し、コード実行サーバーでCSVを集計する。依頼の対象でないBarber 3は比較に含めない。</a:t>
             </a:r>
           </a:p>
         </p:txBody>
@@ -27019,23 +27019,23 @@
                 <a:spcPct val="110000"/>
               </a:lnSpc>
               <a:buNone/>
-              <a:defRPr sz="2800" b="0">
-                <a:solidFill>
-                  <a:srgbClr val="303437"/>
-                </a:solidFill>
-                <a:latin typeface="Noto Sans"/>
-              </a:defRPr>
-            </a:pPr>
-            <a:r>
-              <a:rPr sz="2800" b="1" lang="ja-JP" altLang="en-US">
-                <a:solidFill>
-                  <a:srgbClr val="303437"/>
-                </a:solidFill>
-                <a:latin typeface="Noto Sans"/>
-                <a:ea typeface="Noto Sans CJK JP"/>
-                <a:cs typeface="Noto Sans"/>
-              </a:rPr>
-              <a:t>36サーバーのうち、検索系は多くの課題で使う</a:t>
+              <a:defRPr sz="2500" b="0">
+                <a:solidFill>
+                  <a:srgbClr val="303437"/>
+                </a:solidFill>
+                <a:latin typeface="Noto Sans"/>
+              </a:defRPr>
+            </a:pPr>
+            <a:r>
+              <a:rPr sz="2500" b="1" lang="ja-JP" altLang="en-US">
+                <a:solidFill>
+                  <a:srgbClr val="303437"/>
+                </a:solidFill>
+                <a:latin typeface="Noto Sans"/>
+                <a:ea typeface="Noto Sans CJK JP"/>
+                <a:cs typeface="Noto Sans"/>
+              </a:rPr>
+              <a:t>36サーバーのうち、検索系は多くの課題で使われる</a:t>
             </a:r>
           </a:p>
         </p:txBody>
@@ -28111,7 +28111,7 @@
                 <a:ea typeface="Noto Sans CJK JP"/>
                 <a:cs typeface="Noto Sans"/>
               </a:rPr>
-              <a:t>参照の操作履歴は、1課題あたり平均9.8回のツール呼び出し。</a:t>
+              <a:t>参照の操作履歴におけるツール呼び出しは、1課題あたり平均9.8回。</a:t>
             </a:r>
           </a:p>
         </p:txBody>
@@ -28630,7 +28630,7 @@
                           <a:ea typeface="Noto Sans CJK JP"/>
                           <a:cs typeface="Noto Sans"/>
                         </a:rPr>
-                        <a:t>ツールの選択違い</a:t>
+                        <a:t>ツールの選択誤り</a:t>
                       </a:r>
                     </a:p>
                   </a:txBody>
@@ -28680,7 +28680,7 @@
                           <a:ea typeface="Noto Sans CJK JP"/>
                           <a:cs typeface="Noto Sans"/>
                         </a:rPr>
-                        <a:t>依頼を解けないツールを選ぶ</a:t>
+                        <a:t>依頼に対応できないツールを選ぶ</a:t>
                       </a:r>
                     </a:p>
                   </a:txBody>
@@ -36550,7 +36550,7 @@
                 <a:ea typeface="Noto Sans CJK JP"/>
                 <a:cs typeface="Noto Sans"/>
               </a:rPr>
-              <a:t>参照履歴はGitHubで対象リポジトリを確認し、</a:t>
+              <a:t>参照履歴ではGitHubで対象リポジトリを確認し、</a:t>
             </a:r>
           </a:p>
           <a:p>

</xml_diff>